<commit_message>
Update and finishing the project.
</commit_message>
<xml_diff>
--- a/Contexto Projeto.pptx
+++ b/Contexto Projeto.pptx
@@ -5,34 +5,29 @@
     <p:sldMasterId id="2147483648" r:id="rId1"/>
   </p:sldMasterIdLst>
   <p:notesMasterIdLst>
-    <p:notesMasterId r:id="rId6"/>
+    <p:notesMasterId r:id="rId8"/>
   </p:notesMasterIdLst>
   <p:sldIdLst>
     <p:sldId id="256" r:id="rId2"/>
-    <p:sldId id="260" r:id="rId3"/>
-    <p:sldId id="257" r:id="rId4"/>
-    <p:sldId id="263" r:id="rId5"/>
+    <p:sldId id="264" r:id="rId3"/>
+    <p:sldId id="265" r:id="rId4"/>
+    <p:sldId id="260" r:id="rId5"/>
+    <p:sldId id="257" r:id="rId6"/>
+    <p:sldId id="263" r:id="rId7"/>
   </p:sldIdLst>
   <p:sldSz cx="12192000" cy="6858000"/>
   <p:notesSz cx="6858000" cy="9144000"/>
   <p:embeddedFontLst>
     <p:embeddedFont>
       <p:font typeface="Bebas Neue" panose="020B0606020202050201" pitchFamily="34" charset="0"/>
-      <p:regular r:id="rId7"/>
-    </p:embeddedFont>
-    <p:embeddedFont>
-      <p:font typeface="Calibri" panose="020F0502020204030204" pitchFamily="34" charset="0"/>
-      <p:regular r:id="rId8"/>
-      <p:bold r:id="rId9"/>
-      <p:italic r:id="rId10"/>
-      <p:boldItalic r:id="rId11"/>
+      <p:regular r:id="rId9"/>
     </p:embeddedFont>
     <p:embeddedFont>
       <p:font typeface="Poppins" panose="00000500000000000000" pitchFamily="2" charset="0"/>
-      <p:regular r:id="rId12"/>
-      <p:bold r:id="rId13"/>
-      <p:italic r:id="rId14"/>
-      <p:boldItalic r:id="rId15"/>
+      <p:regular r:id="rId10"/>
+      <p:bold r:id="rId11"/>
+      <p:italic r:id="rId12"/>
+      <p:boldItalic r:id="rId13"/>
     </p:embeddedFont>
   </p:embeddedFontLst>
   <p:defaultTextStyle>
@@ -269,7 +264,7 @@
       <p15:sldGuideLst xmlns:p15="http://schemas.microsoft.com/office/powerpoint/2012/main"/>
     </p:ext>
     <p:ext uri="GoogleSlidesCustomDataVersion2">
-      <go:slidesCustomData xmlns="" xmlns:mc="http://schemas.openxmlformats.org/markup-compatibility/2006" xmlns:mv="urn:schemas-microsoft-com:mac:vml" xmlns:c="http://schemas.openxmlformats.org/drawingml/2006/chart" xmlns:dgm="http://schemas.openxmlformats.org/drawingml/2006/diagram" xmlns:o="urn:schemas-microsoft-com:office:office" xmlns:v="urn:schemas-microsoft-com:vml" xmlns:pvml="urn:schemas-microsoft-com:office:powerpoint" xmlns:com="http://schemas.openxmlformats.org/drawingml/2006/compatibility" xmlns:p14="http://schemas.microsoft.com/office/powerpoint/2010/main" xmlns:p15="http://schemas.microsoft.com/office/powerpoint/2012/main" xmlns:ahyp="http://schemas.microsoft.com/office/drawing/2018/hyperlinkcolor" xmlns:go="http://customooxmlschemas.google.com/" r:id="rId53" roundtripDataSignature="AMtx7mi2l8lzuNDSRJJYLLe1IbgraTvBnQ=="/>
+      <go:slidesCustomData xmlns:go="http://customooxmlschemas.google.com/" xmlns:ahyp="http://schemas.microsoft.com/office/drawing/2018/hyperlinkcolor" xmlns:p15="http://schemas.microsoft.com/office/powerpoint/2012/main" xmlns:p14="http://schemas.microsoft.com/office/powerpoint/2010/main" xmlns:com="http://schemas.openxmlformats.org/drawingml/2006/compatibility" xmlns:pvml="urn:schemas-microsoft-com:office:powerpoint" xmlns:v="urn:schemas-microsoft-com:vml" xmlns:o="urn:schemas-microsoft-com:office:office" xmlns:dgm="http://schemas.openxmlformats.org/drawingml/2006/diagram" xmlns:c="http://schemas.openxmlformats.org/drawingml/2006/chart" xmlns:mv="urn:schemas-microsoft-com:mac:vml" xmlns:mc="http://schemas.openxmlformats.org/markup-compatibility/2006" xmlns="" r:id="rId53" roundtripDataSignature="AMtx7mi2l8lzuNDSRJJYLLe1IbgraTvBnQ=="/>
     </p:ext>
   </p:extLst>
 </p:presentation>
@@ -1479,7 +1474,7 @@
                 <a:cs typeface="Calibri"/>
                 <a:sym typeface="Calibri"/>
               </a:rPr>
-              <a:t>‹#›</a:t>
+              <a:t>‹nº›</a:t>
             </a:fld>
             <a:endParaRPr sz="1200" b="0" i="0" u="none" strike="noStrike" cap="none">
               <a:solidFill>
@@ -1787,7 +1782,7 @@
               <a:buSzPts val="1400"/>
               <a:buNone/>
             </a:pPr>
-            <a:endParaRPr/>
+            <a:endParaRPr dirty="0"/>
           </a:p>
         </p:txBody>
       </p:sp>
@@ -3490,7 +3485,7 @@
             </a:pPr>
             <a:fld id="{00000000-1234-1234-1234-123412341234}" type="slidenum">
               <a:rPr lang="pt-BR"/>
-              <a:t>‹#›</a:t>
+              <a:t>‹nº›</a:t>
             </a:fld>
             <a:endParaRPr/>
           </a:p>
@@ -4191,7 +4186,7 @@
             </a:pPr>
             <a:fld id="{00000000-1234-1234-1234-123412341234}" type="slidenum">
               <a:rPr lang="pt-BR"/>
-              <a:t>‹#›</a:t>
+              <a:t>‹nº›</a:t>
             </a:fld>
             <a:endParaRPr/>
           </a:p>
@@ -5056,7 +5051,7 @@
             </a:pPr>
             <a:fld id="{00000000-1234-1234-1234-123412341234}" type="slidenum">
               <a:rPr lang="pt-BR"/>
-              <a:t>‹#›</a:t>
+              <a:t>‹nº›</a:t>
             </a:fld>
             <a:endParaRPr/>
           </a:p>
@@ -5965,7 +5960,7 @@
             </a:pPr>
             <a:fld id="{00000000-1234-1234-1234-123412341234}" type="slidenum">
               <a:rPr lang="pt-BR"/>
-              <a:t>‹#›</a:t>
+              <a:t>‹nº›</a:t>
             </a:fld>
             <a:endParaRPr/>
           </a:p>
@@ -6675,6 +6670,31 @@
 <file path=ppt/slides/slide1.xml><?xml version="1.0" encoding="utf-8"?>
 <p:sld xmlns:a="http://schemas.openxmlformats.org/drawingml/2006/main" xmlns:r="http://schemas.openxmlformats.org/officeDocument/2006/relationships" xmlns:p="http://schemas.openxmlformats.org/presentationml/2006/main">
   <p:cSld>
+    <p:bg>
+      <p:bgPr>
+        <a:gradFill>
+          <a:gsLst>
+            <a:gs pos="0">
+              <a:srgbClr val="210C0F"/>
+            </a:gs>
+            <a:gs pos="74000">
+              <a:srgbClr val="C07E3E"/>
+            </a:gs>
+            <a:gs pos="83000">
+              <a:schemeClr val="accent1">
+                <a:lumMod val="45000"/>
+                <a:lumOff val="55000"/>
+              </a:schemeClr>
+            </a:gs>
+            <a:gs pos="100000">
+              <a:srgbClr val="864472"/>
+            </a:gs>
+          </a:gsLst>
+          <a:lin ang="5400000" scaled="1"/>
+        </a:gradFill>
+        <a:effectLst/>
+      </p:bgPr>
+    </p:bg>
     <p:spTree>
       <p:nvGrpSpPr>
         <p:cNvPr id="1" name="Shape 43"/>
@@ -6840,6 +6860,151 @@
 <file path=ppt/slides/slide2.xml><?xml version="1.0" encoding="utf-8"?>
 <p:sld xmlns:a="http://schemas.openxmlformats.org/drawingml/2006/main" xmlns:r="http://schemas.openxmlformats.org/officeDocument/2006/relationships" xmlns:p="http://schemas.openxmlformats.org/presentationml/2006/main">
   <p:cSld>
+    <p:bg>
+      <p:bgPr>
+        <a:gradFill>
+          <a:gsLst>
+            <a:gs pos="0">
+              <a:srgbClr val="C07E3E"/>
+            </a:gs>
+            <a:gs pos="74000">
+              <a:srgbClr val="C07E3E"/>
+            </a:gs>
+            <a:gs pos="83000">
+              <a:schemeClr val="accent1">
+                <a:lumMod val="45000"/>
+                <a:lumOff val="55000"/>
+              </a:schemeClr>
+            </a:gs>
+            <a:gs pos="100000">
+              <a:schemeClr val="accent1">
+                <a:lumMod val="30000"/>
+                <a:lumOff val="70000"/>
+              </a:schemeClr>
+            </a:gs>
+          </a:gsLst>
+          <a:path path="circle">
+            <a:fillToRect l="100000" b="100000"/>
+          </a:path>
+        </a:gradFill>
+        <a:effectLst/>
+      </p:bgPr>
+    </p:bg>
+    <p:spTree>
+      <p:nvGrpSpPr>
+        <p:cNvPr id="1" name=""/>
+        <p:cNvGrpSpPr/>
+        <p:nvPr/>
+      </p:nvGrpSpPr>
+      <p:grpSpPr>
+        <a:xfrm>
+          <a:off x="0" y="0"/>
+          <a:ext cx="0" cy="0"/>
+          <a:chOff x="0" y="0"/>
+          <a:chExt cx="0" cy="0"/>
+        </a:xfrm>
+      </p:grpSpPr>
+      <p:pic>
+        <p:nvPicPr>
+          <p:cNvPr id="5" name="Imagem 4" descr="Padrão do plano de fundo&#10;&#10;O conteúdo gerado por IA pode estar incorreto.">
+            <a:extLst>
+              <a:ext uri="{FF2B5EF4-FFF2-40B4-BE49-F238E27FC236}">
+                <a16:creationId xmlns:a16="http://schemas.microsoft.com/office/drawing/2014/main" id="{34C50C69-3934-52CD-11EF-28D6CF9115AA}"/>
+              </a:ext>
+            </a:extLst>
+          </p:cNvPr>
+          <p:cNvPicPr>
+            <a:picLocks noChangeAspect="1"/>
+          </p:cNvPicPr>
+          <p:nvPr/>
+        </p:nvPicPr>
+        <p:blipFill>
+          <a:blip r:embed="rId2"/>
+          <a:stretch>
+            <a:fillRect/>
+          </a:stretch>
+        </p:blipFill>
+        <p:spPr>
+          <a:xfrm>
+            <a:off x="0" y="0"/>
+            <a:ext cx="12192000" cy="6858000"/>
+          </a:xfrm>
+          <a:prstGeom prst="rect">
+            <a:avLst/>
+          </a:prstGeom>
+        </p:spPr>
+      </p:pic>
+    </p:spTree>
+    <p:extLst>
+      <p:ext uri="{BB962C8B-B14F-4D97-AF65-F5344CB8AC3E}">
+        <p14:creationId xmlns:p14="http://schemas.microsoft.com/office/powerpoint/2010/main" val="2797829892"/>
+      </p:ext>
+    </p:extLst>
+  </p:cSld>
+  <p:clrMapOvr>
+    <a:masterClrMapping/>
+  </p:clrMapOvr>
+</p:sld>
+</file>
+
+<file path=ppt/slides/slide3.xml><?xml version="1.0" encoding="utf-8"?>
+<p:sld xmlns:a="http://schemas.openxmlformats.org/drawingml/2006/main" xmlns:r="http://schemas.openxmlformats.org/officeDocument/2006/relationships" xmlns:p="http://schemas.openxmlformats.org/presentationml/2006/main">
+  <p:cSld>
+    <p:bg>
+      <p:bgPr>
+        <a:gradFill flip="none" rotWithShape="1">
+          <a:gsLst>
+            <a:gs pos="35000">
+              <a:srgbClr val="864472"/>
+            </a:gs>
+            <a:gs pos="60000">
+              <a:srgbClr val="C07E3E"/>
+            </a:gs>
+            <a:gs pos="83000">
+              <a:srgbClr val="210C0F"/>
+            </a:gs>
+            <a:gs pos="89000">
+              <a:srgbClr val="030101"/>
+            </a:gs>
+          </a:gsLst>
+          <a:path path="circle">
+            <a:fillToRect l="100000" b="100000"/>
+          </a:path>
+          <a:tileRect t="-100000" r="-100000"/>
+        </a:gradFill>
+        <a:effectLst/>
+      </p:bgPr>
+    </p:bg>
+    <p:spTree>
+      <p:nvGrpSpPr>
+        <p:cNvPr id="1" name=""/>
+        <p:cNvGrpSpPr/>
+        <p:nvPr/>
+      </p:nvGrpSpPr>
+      <p:grpSpPr>
+        <a:xfrm>
+          <a:off x="0" y="0"/>
+          <a:ext cx="0" cy="0"/>
+          <a:chOff x="0" y="0"/>
+          <a:chExt cx="0" cy="0"/>
+        </a:xfrm>
+      </p:grpSpPr>
+    </p:spTree>
+    <p:extLst>
+      <p:ext uri="{BB962C8B-B14F-4D97-AF65-F5344CB8AC3E}">
+        <p14:creationId xmlns:p14="http://schemas.microsoft.com/office/powerpoint/2010/main" val="4146936544"/>
+      </p:ext>
+    </p:extLst>
+  </p:cSld>
+  <p:clrMapOvr>
+    <a:masterClrMapping/>
+  </p:clrMapOvr>
+</p:sld>
+</file>
+
+<file path=ppt/slides/slide4.xml><?xml version="1.0" encoding="utf-8"?>
+<p:sld xmlns:a="http://schemas.openxmlformats.org/drawingml/2006/main" xmlns:r="http://schemas.openxmlformats.org/officeDocument/2006/relationships" xmlns:p="http://schemas.openxmlformats.org/presentationml/2006/main">
+  <p:cSld>
     <p:spTree>
       <p:nvGrpSpPr>
         <p:cNvPr id="1" name="Shape 154"/>
@@ -7150,7 +7315,7 @@
 </p:sld>
 </file>
 
-<file path=ppt/slides/slide3.xml><?xml version="1.0" encoding="utf-8"?>
+<file path=ppt/slides/slide5.xml><?xml version="1.0" encoding="utf-8"?>
 <p:sld xmlns:a="http://schemas.openxmlformats.org/drawingml/2006/main" xmlns:r="http://schemas.openxmlformats.org/officeDocument/2006/relationships" xmlns:p="http://schemas.openxmlformats.org/presentationml/2006/main">
   <p:cSld>
     <p:spTree>
@@ -8595,7 +8760,7 @@
 </p:sld>
 </file>
 
-<file path=ppt/slides/slide4.xml><?xml version="1.0" encoding="utf-8"?>
+<file path=ppt/slides/slide6.xml><?xml version="1.0" encoding="utf-8"?>
 <p:sld xmlns:a="http://schemas.openxmlformats.org/drawingml/2006/main" xmlns:r="http://schemas.openxmlformats.org/officeDocument/2006/relationships" xmlns:p="http://schemas.openxmlformats.org/presentationml/2006/main">
   <p:cSld>
     <p:spTree>

</xml_diff>